<commit_message>
README: role, method and before/after explanations; clearer showcase deck layout; refresh previews
</commit_message>
<xml_diff>
--- a/templates/Analytics_KPIs_showcase_tagged.pptx
+++ b/templates/Analytics_KPIs_showcase_tagged.pptx
@@ -3345,7 +3345,7 @@
           </a:prstGeom>
         </p:spPr>
         <p:txBody>
-          <a:bodyPr/>
+          <a:bodyPr wrap="none"/>
           <a:lstStyle/>
           <a:p>
             <a:pPr marL="0" marR="0" lvl="0" indent="0" algn="l" defTabSz="914400" rtl="0" eaLnBrk="1" fontAlgn="auto" latinLnBrk="0" hangingPunct="1">
@@ -3403,7 +3403,7 @@
           </a:prstGeom>
         </p:spPr>
         <p:txBody>
-          <a:bodyPr/>
+          <a:bodyPr wrap="none"/>
           <a:lstStyle/>
           <a:p>
             <a:pPr marL="0" marR="0" lvl="0" indent="0" algn="l" defTabSz="914400" rtl="0" eaLnBrk="1" fontAlgn="auto" latinLnBrk="0" hangingPunct="1">
@@ -3423,13 +3423,13 @@
               <a:tabLst/>
               <a:defRPr/>
             </a:pPr>
-            <a:fld id="{64E38502-06D2-4E51-82FE-464E052045F9}" type="slidenum">
+            <a:r>
               <a:rPr kumimoji="0" lang="en-US" sz="1200" b="0" i="0" u="none" strike="noStrike" kern="1200" cap="none" spc="0" normalizeH="0" baseline="0" noProof="0" smtClean="0">
                 <a:ln>
                   <a:noFill/>
                 </a:ln>
                 <a:solidFill>
-                  <a:srgbClr val="E8ECF4"/>
+                  <a:srgbClr val="9aa1b2"/>
                 </a:solidFill>
                 <a:effectLst/>
                 <a:uLnTx/>
@@ -3438,25 +3438,8 @@
                 <a:ea typeface="+mn-ea"/>
                 <a:cs typeface="+mn-cs"/>
               </a:rPr>
-              <a:pPr marL="0" marR="0" lvl="0" indent="0" algn="l" defTabSz="914400" rtl="0" eaLnBrk="1" fontAlgn="auto" latinLnBrk="0" hangingPunct="1">
-                <a:lnSpc>
-                  <a:spcPct val="100000"/>
-                </a:lnSpc>
-                <a:spcBef>
-                  <a:spcPts val="0"/>
-                </a:spcBef>
-                <a:spcAft>
-                  <a:spcPts val="0"/>
-                </a:spcAft>
-                <a:buClrTx/>
-                <a:buSzTx/>
-                <a:buFontTx/>
-                <a:buNone/>
-                <a:tabLst/>
-                <a:defRPr/>
-              </a:pPr>
               <a:t>10</a:t>
-            </a:fld>
+            </a:r>
             <a:endParaRPr kumimoji="0" lang="en-US" sz="1200" b="0" i="0" u="none" strike="noStrike" kern="1200" cap="none" spc="0" normalizeH="0" baseline="0" noProof="0">
               <a:ln>
                 <a:noFill/>
@@ -3739,8 +3722,8 @@
         </p:nvSpPr>
         <p:spPr>
           <a:xfrm>
-            <a:off x="835774" y="5732395"/>
-            <a:ext cx="8229484" cy="378779"/>
+            <a:off x="835774" y="5582395"/>
+            <a:ext cx="8229484" cy="640000"/>
           </a:xfrm>
           <a:prstGeom prst="roundRect">
             <a:avLst>
@@ -4492,7 +4475,7 @@
           </a:prstGeom>
         </p:spPr>
         <p:txBody>
-          <a:bodyPr/>
+          <a:bodyPr wrap="none"/>
           <a:lstStyle/>
           <a:p>
             <a:pPr marL="0" marR="0" lvl="0" indent="0" algn="l" defTabSz="914400" rtl="0" eaLnBrk="1" fontAlgn="auto" latinLnBrk="0" hangingPunct="1">
@@ -4550,7 +4533,7 @@
           </a:prstGeom>
         </p:spPr>
         <p:txBody>
-          <a:bodyPr/>
+          <a:bodyPr wrap="none"/>
           <a:lstStyle/>
           <a:p>
             <a:pPr marL="0" marR="0" lvl="0" indent="0" algn="l" defTabSz="914400" rtl="0" eaLnBrk="1" fontAlgn="auto" latinLnBrk="0" hangingPunct="1">
@@ -4570,13 +4553,13 @@
               <a:tabLst/>
               <a:defRPr/>
             </a:pPr>
-            <a:fld id="{64E38502-06D2-4E51-82FE-464E052045F9}" type="slidenum">
+            <a:r>
               <a:rPr kumimoji="0" lang="en-US" sz="1200" b="0" i="0" u="none" strike="noStrike" kern="1200" cap="none" spc="0" normalizeH="0" baseline="0" noProof="0" smtClean="0">
                 <a:ln>
                   <a:noFill/>
                 </a:ln>
                 <a:solidFill>
-                  <a:srgbClr val="E8ECF4"/>
+                  <a:srgbClr val="9aa1b2"/>
                 </a:solidFill>
                 <a:effectLst/>
                 <a:uLnTx/>
@@ -4585,25 +4568,8 @@
                 <a:ea typeface="+mn-ea"/>
                 <a:cs typeface="+mn-cs"/>
               </a:rPr>
-              <a:pPr marL="0" marR="0" lvl="0" indent="0" algn="l" defTabSz="914400" rtl="0" eaLnBrk="1" fontAlgn="auto" latinLnBrk="0" hangingPunct="1">
-                <a:lnSpc>
-                  <a:spcPct val="100000"/>
-                </a:lnSpc>
-                <a:spcBef>
-                  <a:spcPts val="0"/>
-                </a:spcBef>
-                <a:spcAft>
-                  <a:spcPts val="0"/>
-                </a:spcAft>
-                <a:buClrTx/>
-                <a:buSzTx/>
-                <a:buFontTx/>
-                <a:buNone/>
-                <a:tabLst/>
-                <a:defRPr/>
-              </a:pPr>
               <a:t>11</a:t>
-            </a:fld>
+            </a:r>
             <a:endParaRPr kumimoji="0" lang="en-US" sz="1200" b="0" i="0" u="none" strike="noStrike" kern="1200" cap="none" spc="0" normalizeH="0" baseline="0" noProof="0">
               <a:ln>
                 <a:noFill/>
@@ -4870,8 +4836,8 @@
         </p:nvSpPr>
         <p:spPr>
           <a:xfrm>
-            <a:off x="835774" y="5732395"/>
-            <a:ext cx="8229484" cy="378779"/>
+            <a:off x="835774" y="5582395"/>
+            <a:ext cx="8229484" cy="640000"/>
           </a:xfrm>
           <a:prstGeom prst="roundRect">
             <a:avLst>
@@ -6364,7 +6330,7 @@
           </a:prstGeom>
         </p:spPr>
         <p:txBody>
-          <a:bodyPr/>
+          <a:bodyPr wrap="none"/>
           <a:lstStyle/>
           <a:p>
             <a:pPr marL="0" marR="0" lvl="0" indent="0" algn="l" defTabSz="914400" rtl="0" eaLnBrk="1" fontAlgn="auto" latinLnBrk="0" hangingPunct="1">
@@ -6422,7 +6388,7 @@
           </a:prstGeom>
         </p:spPr>
         <p:txBody>
-          <a:bodyPr/>
+          <a:bodyPr wrap="none"/>
           <a:lstStyle/>
           <a:p>
             <a:pPr marL="0" marR="0" lvl="0" indent="0" algn="l" defTabSz="914400" rtl="0" eaLnBrk="1" fontAlgn="auto" latinLnBrk="0" hangingPunct="1">
@@ -6442,13 +6408,13 @@
               <a:tabLst/>
               <a:defRPr/>
             </a:pPr>
-            <a:fld id="{64E38502-06D2-4E51-82FE-464E052045F9}" type="slidenum">
+            <a:r>
               <a:rPr kumimoji="0" lang="en-US" sz="1200" b="0" i="0" u="none" strike="noStrike" kern="1200" cap="none" spc="0" normalizeH="0" baseline="0" noProof="0" smtClean="0">
                 <a:ln>
                   <a:noFill/>
                 </a:ln>
                 <a:solidFill>
-                  <a:srgbClr val="E8ECF4"/>
+                  <a:srgbClr val="9aa1b2"/>
                 </a:solidFill>
                 <a:effectLst/>
                 <a:uLnTx/>
@@ -6457,25 +6423,8 @@
                 <a:ea typeface="+mn-ea"/>
                 <a:cs typeface="+mn-cs"/>
               </a:rPr>
-              <a:pPr marL="0" marR="0" lvl="0" indent="0" algn="l" defTabSz="914400" rtl="0" eaLnBrk="1" fontAlgn="auto" latinLnBrk="0" hangingPunct="1">
-                <a:lnSpc>
-                  <a:spcPct val="100000"/>
-                </a:lnSpc>
-                <a:spcBef>
-                  <a:spcPts val="0"/>
-                </a:spcBef>
-                <a:spcAft>
-                  <a:spcPts val="0"/>
-                </a:spcAft>
-                <a:buClrTx/>
-                <a:buSzTx/>
-                <a:buFontTx/>
-                <a:buNone/>
-                <a:tabLst/>
-                <a:defRPr/>
-              </a:pPr>
               <a:t>12</a:t>
-            </a:fld>
+            </a:r>
             <a:endParaRPr kumimoji="0" lang="en-US" sz="1200" b="0" i="0" u="none" strike="noStrike" kern="1200" cap="none" spc="0" normalizeH="0" baseline="0" noProof="0">
               <a:ln>
                 <a:noFill/>
@@ -6742,8 +6691,8 @@
         </p:nvSpPr>
         <p:spPr>
           <a:xfrm>
-            <a:off x="835774" y="5732395"/>
-            <a:ext cx="8229484" cy="378779"/>
+            <a:off x="835774" y="5582395"/>
+            <a:ext cx="8229484" cy="640000"/>
           </a:xfrm>
           <a:prstGeom prst="roundRect">
             <a:avLst>
@@ -8181,7 +8130,7 @@
           </a:prstGeom>
         </p:spPr>
         <p:txBody>
-          <a:bodyPr/>
+          <a:bodyPr wrap="none"/>
           <a:lstStyle/>
           <a:p>
             <a:r>
@@ -8214,7 +8163,7 @@
           </a:prstGeom>
         </p:spPr>
         <p:txBody>
-          <a:bodyPr/>
+          <a:bodyPr wrap="none"/>
           <a:lstStyle/>
           <a:p>
             <a:r>
@@ -8246,19 +8195,18 @@
           </a:prstGeom>
         </p:spPr>
         <p:txBody>
-          <a:bodyPr/>
+          <a:bodyPr wrap="none"/>
           <a:lstStyle/>
           <a:p>
             <a:pPr algn="l"/>
-            <a:fld id="{64E38502-06D2-4E51-82FE-464E052045F9}" type="slidenum">
-              <a:rPr lang="en-GB" smtClean="0">
-                <a:solidFill>
-                  <a:srgbClr val="E8ECF4"/>
-                </a:solidFill>
-              </a:rPr>
-              <a:pPr algn="l"/>
+            <a:r>
+              <a:rPr lang="en-GB" smtClean="0" sz="900">
+                <a:solidFill>
+                  <a:srgbClr val="9aa1b2"/>
+                </a:solidFill>
+              </a:rPr>
               <a:t>13</a:t>
-            </a:fld>
+            </a:r>
             <a:endParaRPr lang="en-GB"/>
           </a:p>
         </p:txBody>
@@ -9262,7 +9210,7 @@
           </a:prstGeom>
         </p:spPr>
         <p:txBody>
-          <a:bodyPr/>
+          <a:bodyPr wrap="none"/>
           <a:lstStyle/>
           <a:p>
             <a:pPr marL="0" marR="0" lvl="0" indent="0" algn="l" defTabSz="914400" rtl="0" eaLnBrk="1" fontAlgn="auto" latinLnBrk="0" hangingPunct="1">
@@ -9320,7 +9268,7 @@
           </a:prstGeom>
         </p:spPr>
         <p:txBody>
-          <a:bodyPr/>
+          <a:bodyPr wrap="none"/>
           <a:lstStyle/>
           <a:p>
             <a:pPr marL="0" marR="0" lvl="0" indent="0" algn="l" defTabSz="914400" rtl="0" eaLnBrk="1" fontAlgn="auto" latinLnBrk="0" hangingPunct="1">
@@ -9340,13 +9288,13 @@
               <a:tabLst/>
               <a:defRPr/>
             </a:pPr>
-            <a:fld id="{64E38502-06D2-4E51-82FE-464E052045F9}" type="slidenum">
+            <a:r>
               <a:rPr kumimoji="0" lang="en-US" sz="1200" b="0" i="0" u="none" strike="noStrike" kern="1200" cap="none" spc="0" normalizeH="0" baseline="0" noProof="0" smtClean="0">
                 <a:ln>
                   <a:noFill/>
                 </a:ln>
                 <a:solidFill>
-                  <a:srgbClr val="E8ECF4"/>
+                  <a:srgbClr val="9aa1b2"/>
                 </a:solidFill>
                 <a:effectLst/>
                 <a:uLnTx/>
@@ -9355,25 +9303,8 @@
                 <a:ea typeface="+mn-ea"/>
                 <a:cs typeface="+mn-cs"/>
               </a:rPr>
-              <a:pPr marL="0" marR="0" lvl="0" indent="0" algn="l" defTabSz="914400" rtl="0" eaLnBrk="1" fontAlgn="auto" latinLnBrk="0" hangingPunct="1">
-                <a:lnSpc>
-                  <a:spcPct val="100000"/>
-                </a:lnSpc>
-                <a:spcBef>
-                  <a:spcPts val="0"/>
-                </a:spcBef>
-                <a:spcAft>
-                  <a:spcPts val="0"/>
-                </a:spcAft>
-                <a:buClrTx/>
-                <a:buSzTx/>
-                <a:buFontTx/>
-                <a:buNone/>
-                <a:tabLst/>
-                <a:defRPr/>
-              </a:pPr>
               <a:t>14</a:t>
-            </a:fld>
+            </a:r>
             <a:endParaRPr kumimoji="0" lang="en-US" sz="1200" b="0" i="0" u="none" strike="noStrike" kern="1200" cap="none" spc="0" normalizeH="0" baseline="0" noProof="0">
               <a:ln>
                 <a:noFill/>
@@ -10533,7 +10464,7 @@
           </a:prstGeom>
         </p:spPr>
         <p:txBody>
-          <a:bodyPr/>
+          <a:bodyPr wrap="none"/>
           <a:lstStyle/>
           <a:p>
             <a:pPr marL="0" marR="0" lvl="0" indent="0" algn="l" defTabSz="914400" rtl="0" eaLnBrk="1" fontAlgn="auto" latinLnBrk="0" hangingPunct="1">
@@ -10591,7 +10522,7 @@
           </a:prstGeom>
         </p:spPr>
         <p:txBody>
-          <a:bodyPr/>
+          <a:bodyPr wrap="none"/>
           <a:lstStyle/>
           <a:p>
             <a:pPr marL="0" marR="0" lvl="0" indent="0" algn="l" defTabSz="914400" rtl="0" eaLnBrk="1" fontAlgn="auto" latinLnBrk="0" hangingPunct="1">
@@ -10611,13 +10542,13 @@
               <a:tabLst/>
               <a:defRPr/>
             </a:pPr>
-            <a:fld id="{64E38502-06D2-4E51-82FE-464E052045F9}" type="slidenum">
+            <a:r>
               <a:rPr kumimoji="0" lang="en-US" sz="1200" b="0" i="0" u="none" strike="noStrike" kern="1200" cap="none" spc="0" normalizeH="0" baseline="0" noProof="0" smtClean="0">
                 <a:ln>
                   <a:noFill/>
                 </a:ln>
                 <a:solidFill>
-                  <a:srgbClr val="E8ECF4"/>
+                  <a:srgbClr val="9aa1b2"/>
                 </a:solidFill>
                 <a:effectLst/>
                 <a:uLnTx/>
@@ -10626,25 +10557,8 @@
                 <a:ea typeface="+mn-ea"/>
                 <a:cs typeface="+mn-cs"/>
               </a:rPr>
-              <a:pPr marL="0" marR="0" lvl="0" indent="0" algn="l" defTabSz="914400" rtl="0" eaLnBrk="1" fontAlgn="auto" latinLnBrk="0" hangingPunct="1">
-                <a:lnSpc>
-                  <a:spcPct val="100000"/>
-                </a:lnSpc>
-                <a:spcBef>
-                  <a:spcPts val="0"/>
-                </a:spcBef>
-                <a:spcAft>
-                  <a:spcPts val="0"/>
-                </a:spcAft>
-                <a:buClrTx/>
-                <a:buSzTx/>
-                <a:buFontTx/>
-                <a:buNone/>
-                <a:tabLst/>
-                <a:defRPr/>
-              </a:pPr>
               <a:t>15</a:t>
-            </a:fld>
+            </a:r>
             <a:endParaRPr kumimoji="0" lang="en-US" sz="1200" b="0" i="0" u="none" strike="noStrike" kern="1200" cap="none" spc="0" normalizeH="0" baseline="0" noProof="0">
               <a:ln>
                 <a:noFill/>
@@ -13389,7 +13303,7 @@
           </a:prstGeom>
         </p:spPr>
         <p:txBody>
-          <a:bodyPr/>
+          <a:bodyPr wrap="none"/>
           <a:lstStyle/>
           <a:p>
             <a:r>
@@ -13422,7 +13336,7 @@
           </a:prstGeom>
         </p:spPr>
         <p:txBody>
-          <a:bodyPr/>
+          <a:bodyPr wrap="none"/>
           <a:lstStyle/>
           <a:p>
             <a:pPr marL="0" marR="0" lvl="0" indent="0" algn="l" defTabSz="914400" rtl="0" eaLnBrk="1" fontAlgn="auto" latinLnBrk="0" hangingPunct="1">
@@ -13483,19 +13397,18 @@
           </a:prstGeom>
         </p:spPr>
         <p:txBody>
-          <a:bodyPr/>
+          <a:bodyPr wrap="none"/>
           <a:lstStyle/>
           <a:p>
             <a:pPr algn="l"/>
-            <a:fld id="{64E38502-06D2-4E51-82FE-464E052045F9}" type="slidenum">
-              <a:rPr lang="en-GB" smtClean="0">
-                <a:solidFill>
-                  <a:srgbClr val="E8ECF4"/>
-                </a:solidFill>
-              </a:rPr>
-              <a:pPr algn="l"/>
+            <a:r>
+              <a:rPr lang="en-GB" smtClean="0" sz="900">
+                <a:solidFill>
+                  <a:srgbClr val="9aa1b2"/>
+                </a:solidFill>
+              </a:rPr>
               <a:t>17</a:t>
-            </a:fld>
+            </a:r>
             <a:endParaRPr lang="en-GB"/>
           </a:p>
         </p:txBody>
@@ -14232,7 +14145,7 @@
                         <a:srgbClr val="7E8789"/>
                       </a:solidFill>
                     </a:rPr>
-                    <a:t>Paritcipation</a:t>
+                    <a:t>Participation</a:t>
                   </a:r>
                   <a:r>
                     <a:rPr lang="en-US" sz="900" b="1">
@@ -14717,7 +14630,7 @@
           </a:prstGeom>
         </p:spPr>
         <p:txBody>
-          <a:bodyPr/>
+          <a:bodyPr wrap="none"/>
           <a:lstStyle/>
           <a:p>
             <a:r>
@@ -14750,7 +14663,7 @@
           </a:prstGeom>
         </p:spPr>
         <p:txBody>
-          <a:bodyPr/>
+          <a:bodyPr wrap="none"/>
           <a:lstStyle/>
           <a:p>
             <a:pPr marL="0" marR="0" lvl="0" indent="0" algn="l" defTabSz="914400" rtl="0" eaLnBrk="1" fontAlgn="auto" latinLnBrk="0" hangingPunct="1">
@@ -14811,19 +14724,18 @@
           </a:prstGeom>
         </p:spPr>
         <p:txBody>
-          <a:bodyPr/>
+          <a:bodyPr wrap="none"/>
           <a:lstStyle/>
           <a:p>
             <a:pPr algn="l"/>
-            <a:fld id="{64E38502-06D2-4E51-82FE-464E052045F9}" type="slidenum">
-              <a:rPr lang="en-GB" smtClean="0">
-                <a:solidFill>
-                  <a:srgbClr val="E8ECF4"/>
-                </a:solidFill>
-              </a:rPr>
-              <a:pPr algn="l"/>
+            <a:r>
+              <a:rPr lang="en-GB" smtClean="0" sz="900">
+                <a:solidFill>
+                  <a:srgbClr val="9aa1b2"/>
+                </a:solidFill>
+              </a:rPr>
               <a:t>18</a:t>
-            </a:fld>
+            </a:r>
             <a:endParaRPr lang="en-GB"/>
           </a:p>
         </p:txBody>
@@ -16058,7 +15970,7 @@
           </a:prstGeom>
         </p:spPr>
         <p:txBody>
-          <a:bodyPr/>
+          <a:bodyPr wrap="none"/>
           <a:lstStyle/>
           <a:p>
             <a:r>
@@ -20137,7 +20049,7 @@
           </a:prstGeom>
         </p:spPr>
         <p:txBody>
-          <a:bodyPr/>
+          <a:bodyPr wrap="none"/>
           <a:lstStyle/>
           <a:p>
             <a:r>
@@ -20170,7 +20082,7 @@
           </a:prstGeom>
         </p:spPr>
         <p:txBody>
-          <a:bodyPr/>
+          <a:bodyPr wrap="none"/>
           <a:lstStyle/>
           <a:p>
             <a:r>
@@ -20202,17 +20114,17 @@
           </a:prstGeom>
         </p:spPr>
         <p:txBody>
-          <a:bodyPr/>
-          <a:lstStyle/>
-          <a:p>
-            <a:fld id="{3D9E2BD8-1A72-4EDA-80D1-87938489E536}" type="slidenum">
-              <a:rPr lang="de-AT" smtClean="0">
-                <a:solidFill>
-                  <a:srgbClr val="E8ECF4"/>
+          <a:bodyPr wrap="none"/>
+          <a:lstStyle/>
+          <a:p>
+            <a:r>
+              <a:rPr lang="de-AT" smtClean="0" sz="900">
+                <a:solidFill>
+                  <a:srgbClr val="9aa1b2"/>
                 </a:solidFill>
               </a:rPr>
               <a:t>20</a:t>
-            </a:fld>
+            </a:r>
             <a:endParaRPr lang="de-AT"/>
           </a:p>
         </p:txBody>
@@ -20504,7 +20416,7 @@
           </a:prstGeom>
         </p:spPr>
         <p:txBody>
-          <a:bodyPr/>
+          <a:bodyPr wrap="none"/>
           <a:lstStyle/>
           <a:p>
             <a:r>
@@ -20537,7 +20449,7 @@
           </a:prstGeom>
         </p:spPr>
         <p:txBody>
-          <a:bodyPr/>
+          <a:bodyPr wrap="none"/>
           <a:lstStyle/>
           <a:p>
             <a:pPr marL="0" marR="0" lvl="0" indent="0" algn="l" defTabSz="914400" rtl="0" eaLnBrk="1" fontAlgn="auto" latinLnBrk="0" hangingPunct="1">
@@ -20598,19 +20510,18 @@
           </a:prstGeom>
         </p:spPr>
         <p:txBody>
-          <a:bodyPr/>
+          <a:bodyPr wrap="none"/>
           <a:lstStyle/>
           <a:p>
             <a:pPr algn="l"/>
-            <a:fld id="{64E38502-06D2-4E51-82FE-464E052045F9}" type="slidenum">
-              <a:rPr lang="en-GB" smtClean="0">
-                <a:solidFill>
-                  <a:srgbClr val="E8ECF4"/>
-                </a:solidFill>
-              </a:rPr>
-              <a:pPr algn="l"/>
+            <a:r>
+              <a:rPr lang="en-GB" smtClean="0" sz="900">
+                <a:solidFill>
+                  <a:srgbClr val="9aa1b2"/>
+                </a:solidFill>
+              </a:rPr>
               <a:t>21</a:t>
-            </a:fld>
+            </a:r>
             <a:endParaRPr lang="en-GB"/>
           </a:p>
         </p:txBody>
@@ -21649,7 +21560,7 @@
           </a:prstGeom>
         </p:spPr>
         <p:txBody>
-          <a:bodyPr/>
+          <a:bodyPr wrap="none"/>
           <a:lstStyle/>
           <a:p>
             <a:r>
@@ -21682,7 +21593,7 @@
           </a:prstGeom>
         </p:spPr>
         <p:txBody>
-          <a:bodyPr/>
+          <a:bodyPr wrap="none"/>
           <a:lstStyle/>
           <a:p>
             <a:pPr marL="0" marR="0" lvl="0" indent="0" algn="l" defTabSz="914400" rtl="0" eaLnBrk="1" fontAlgn="auto" latinLnBrk="0" hangingPunct="1">
@@ -21743,19 +21654,18 @@
           </a:prstGeom>
         </p:spPr>
         <p:txBody>
-          <a:bodyPr/>
+          <a:bodyPr wrap="none"/>
           <a:lstStyle/>
           <a:p>
             <a:pPr algn="l"/>
-            <a:fld id="{64E38502-06D2-4E51-82FE-464E052045F9}" type="slidenum">
-              <a:rPr lang="en-GB" smtClean="0">
-                <a:solidFill>
-                  <a:srgbClr val="E8ECF4"/>
-                </a:solidFill>
-              </a:rPr>
-              <a:pPr algn="l"/>
+            <a:r>
+              <a:rPr lang="en-GB" smtClean="0" sz="900">
+                <a:solidFill>
+                  <a:srgbClr val="9aa1b2"/>
+                </a:solidFill>
+              </a:rPr>
               <a:t>22</a:t>
-            </a:fld>
+            </a:r>
             <a:endParaRPr lang="en-GB"/>
           </a:p>
         </p:txBody>
@@ -22808,7 +22718,7 @@
           </a:prstGeom>
         </p:spPr>
         <p:txBody>
-          <a:bodyPr/>
+          <a:bodyPr wrap="none"/>
           <a:lstStyle/>
           <a:p>
             <a:r>
@@ -22841,7 +22751,7 @@
           </a:prstGeom>
         </p:spPr>
         <p:txBody>
-          <a:bodyPr/>
+          <a:bodyPr wrap="none"/>
           <a:lstStyle/>
           <a:p>
             <a:pPr marL="0" marR="0" lvl="0" indent="0" algn="l" defTabSz="914400" rtl="0" eaLnBrk="1" fontAlgn="auto" latinLnBrk="0" hangingPunct="1">
@@ -22902,19 +22812,18 @@
           </a:prstGeom>
         </p:spPr>
         <p:txBody>
-          <a:bodyPr/>
+          <a:bodyPr wrap="none"/>
           <a:lstStyle/>
           <a:p>
             <a:pPr algn="l"/>
-            <a:fld id="{64E38502-06D2-4E51-82FE-464E052045F9}" type="slidenum">
-              <a:rPr lang="en-GB" smtClean="0">
-                <a:solidFill>
-                  <a:srgbClr val="E8ECF4"/>
-                </a:solidFill>
-              </a:rPr>
-              <a:pPr algn="l"/>
+            <a:r>
+              <a:rPr lang="en-GB" smtClean="0" sz="900">
+                <a:solidFill>
+                  <a:srgbClr val="9aa1b2"/>
+                </a:solidFill>
+              </a:rPr>
               <a:t>23</a:t>
-            </a:fld>
+            </a:r>
             <a:endParaRPr lang="en-GB"/>
           </a:p>
         </p:txBody>
@@ -24752,7 +24661,7 @@
           </a:prstGeom>
         </p:spPr>
         <p:txBody>
-          <a:bodyPr/>
+          <a:bodyPr wrap="none"/>
           <a:lstStyle/>
           <a:p>
             <a:r>
@@ -24785,7 +24694,7 @@
           </a:prstGeom>
         </p:spPr>
         <p:txBody>
-          <a:bodyPr/>
+          <a:bodyPr wrap="none"/>
           <a:lstStyle/>
           <a:p>
             <a:pPr marL="0" marR="0" lvl="0" indent="0" algn="l" defTabSz="914400" rtl="0" eaLnBrk="1" fontAlgn="auto" latinLnBrk="0" hangingPunct="1">
@@ -24846,19 +24755,18 @@
           </a:prstGeom>
         </p:spPr>
         <p:txBody>
-          <a:bodyPr/>
+          <a:bodyPr wrap="none"/>
           <a:lstStyle/>
           <a:p>
             <a:pPr algn="l"/>
-            <a:fld id="{64E38502-06D2-4E51-82FE-464E052045F9}" type="slidenum">
-              <a:rPr lang="en-GB" smtClean="0">
-                <a:solidFill>
-                  <a:srgbClr val="E8ECF4"/>
-                </a:solidFill>
-              </a:rPr>
-              <a:pPr algn="l"/>
+            <a:r>
+              <a:rPr lang="en-GB" smtClean="0" sz="900">
+                <a:solidFill>
+                  <a:srgbClr val="9aa1b2"/>
+                </a:solidFill>
+              </a:rPr>
               <a:t>25</a:t>
-            </a:fld>
+            </a:r>
             <a:endParaRPr lang="en-GB"/>
           </a:p>
         </p:txBody>
@@ -26353,7 +26261,7 @@
           </a:prstGeom>
         </p:spPr>
         <p:txBody>
-          <a:bodyPr/>
+          <a:bodyPr wrap="none"/>
           <a:lstStyle/>
           <a:p>
             <a:r>
@@ -26386,7 +26294,7 @@
           </a:prstGeom>
         </p:spPr>
         <p:txBody>
-          <a:bodyPr/>
+          <a:bodyPr wrap="none"/>
           <a:lstStyle/>
           <a:p>
             <a:r>
@@ -26418,19 +26326,18 @@
           </a:prstGeom>
         </p:spPr>
         <p:txBody>
-          <a:bodyPr/>
+          <a:bodyPr wrap="none"/>
           <a:lstStyle/>
           <a:p>
             <a:pPr algn="l"/>
-            <a:fld id="{64E38502-06D2-4E51-82FE-464E052045F9}" type="slidenum">
-              <a:rPr lang="en-GB" smtClean="0">
-                <a:solidFill>
-                  <a:srgbClr val="E8ECF4"/>
-                </a:solidFill>
-              </a:rPr>
-              <a:pPr algn="l"/>
+            <a:r>
+              <a:rPr lang="en-GB" smtClean="0" sz="900">
+                <a:solidFill>
+                  <a:srgbClr val="9aa1b2"/>
+                </a:solidFill>
+              </a:rPr>
               <a:t>4</a:t>
-            </a:fld>
+            </a:r>
             <a:endParaRPr lang="en-GB"/>
           </a:p>
         </p:txBody>
@@ -27216,7 +27123,7 @@
           </a:prstGeom>
         </p:spPr>
         <p:txBody>
-          <a:bodyPr/>
+          <a:bodyPr wrap="none"/>
           <a:lstStyle/>
           <a:p>
             <a:r>
@@ -27249,7 +27156,7 @@
           </a:prstGeom>
         </p:spPr>
         <p:txBody>
-          <a:bodyPr/>
+          <a:bodyPr wrap="none"/>
           <a:lstStyle/>
           <a:p>
             <a:r>
@@ -27281,19 +27188,18 @@
           </a:prstGeom>
         </p:spPr>
         <p:txBody>
-          <a:bodyPr/>
+          <a:bodyPr wrap="none"/>
           <a:lstStyle/>
           <a:p>
             <a:pPr algn="l"/>
-            <a:fld id="{64E38502-06D2-4E51-82FE-464E052045F9}" type="slidenum">
-              <a:rPr lang="en-GB" smtClean="0">
-                <a:solidFill>
-                  <a:srgbClr val="E8ECF4"/>
-                </a:solidFill>
-              </a:rPr>
-              <a:pPr algn="l"/>
+            <a:r>
+              <a:rPr lang="en-GB" smtClean="0" sz="900">
+                <a:solidFill>
+                  <a:srgbClr val="9aa1b2"/>
+                </a:solidFill>
+              </a:rPr>
               <a:t>5</a:t>
-            </a:fld>
+            </a:r>
             <a:endParaRPr lang="en-GB"/>
           </a:p>
         </p:txBody>
@@ -28117,7 +28023,7 @@
           </a:prstGeom>
         </p:spPr>
         <p:txBody>
-          <a:bodyPr/>
+          <a:bodyPr wrap="none"/>
           <a:lstStyle/>
           <a:p>
             <a:r>
@@ -28150,7 +28056,7 @@
           </a:prstGeom>
         </p:spPr>
         <p:txBody>
-          <a:bodyPr/>
+          <a:bodyPr wrap="none"/>
           <a:lstStyle/>
           <a:p>
             <a:r>
@@ -28182,19 +28088,18 @@
           </a:prstGeom>
         </p:spPr>
         <p:txBody>
-          <a:bodyPr/>
+          <a:bodyPr wrap="none"/>
           <a:lstStyle/>
           <a:p>
             <a:pPr algn="l"/>
-            <a:fld id="{64E38502-06D2-4E51-82FE-464E052045F9}" type="slidenum">
-              <a:rPr lang="en-GB" smtClean="0">
-                <a:solidFill>
-                  <a:srgbClr val="E8ECF4"/>
-                </a:solidFill>
-              </a:rPr>
-              <a:pPr algn="l"/>
+            <a:r>
+              <a:rPr lang="en-GB" smtClean="0" sz="900">
+                <a:solidFill>
+                  <a:srgbClr val="9aa1b2"/>
+                </a:solidFill>
+              </a:rPr>
               <a:t>6</a:t>
-            </a:fld>
+            </a:r>
             <a:endParaRPr lang="en-GB"/>
           </a:p>
         </p:txBody>
@@ -28207,8 +28112,8 @@
         </p:nvSpPr>
         <p:spPr>
           <a:xfrm>
-            <a:off x="867395" y="5804443"/>
-            <a:ext cx="6313706" cy="332882"/>
+            <a:off x="867395" y="5654443"/>
+            <a:ext cx="6313706" cy="640000"/>
           </a:xfrm>
           <a:prstGeom prst="roundRect">
             <a:avLst>
@@ -29079,7 +28984,7 @@
           </a:prstGeom>
         </p:spPr>
         <p:txBody>
-          <a:bodyPr/>
+          <a:bodyPr wrap="none"/>
           <a:lstStyle/>
           <a:p>
             <a:r>
@@ -29112,7 +29017,7 @@
           </a:prstGeom>
         </p:spPr>
         <p:txBody>
-          <a:bodyPr/>
+          <a:bodyPr wrap="none"/>
           <a:lstStyle/>
           <a:p>
             <a:r>
@@ -29144,19 +29049,18 @@
           </a:prstGeom>
         </p:spPr>
         <p:txBody>
-          <a:bodyPr/>
+          <a:bodyPr wrap="none"/>
           <a:lstStyle/>
           <a:p>
             <a:pPr algn="l"/>
-            <a:fld id="{64E38502-06D2-4E51-82FE-464E052045F9}" type="slidenum">
-              <a:rPr lang="en-GB" smtClean="0">
-                <a:solidFill>
-                  <a:srgbClr val="E8ECF4"/>
-                </a:solidFill>
-              </a:rPr>
-              <a:pPr algn="l"/>
+            <a:r>
+              <a:rPr lang="en-GB" smtClean="0" sz="900">
+                <a:solidFill>
+                  <a:srgbClr val="9aa1b2"/>
+                </a:solidFill>
+              </a:rPr>
               <a:t>7</a:t>
-            </a:fld>
+            </a:r>
             <a:endParaRPr lang="en-GB"/>
           </a:p>
         </p:txBody>
@@ -29169,8 +29073,8 @@
         </p:nvSpPr>
         <p:spPr>
           <a:xfrm>
-            <a:off x="867395" y="5804443"/>
-            <a:ext cx="6313706" cy="332882"/>
+            <a:off x="867395" y="5654443"/>
+            <a:ext cx="6313706" cy="640000"/>
           </a:xfrm>
           <a:prstGeom prst="roundRect">
             <a:avLst>
@@ -30622,7 +30526,7 @@
           </a:prstGeom>
         </p:spPr>
         <p:txBody>
-          <a:bodyPr/>
+          <a:bodyPr wrap="none"/>
           <a:lstStyle/>
           <a:p>
             <a:r>
@@ -30655,7 +30559,7 @@
           </a:prstGeom>
         </p:spPr>
         <p:txBody>
-          <a:bodyPr/>
+          <a:bodyPr wrap="none"/>
           <a:lstStyle/>
           <a:p>
             <a:r>
@@ -30687,19 +30591,18 @@
           </a:prstGeom>
         </p:spPr>
         <p:txBody>
-          <a:bodyPr/>
+          <a:bodyPr wrap="none"/>
           <a:lstStyle/>
           <a:p>
             <a:pPr algn="l"/>
-            <a:fld id="{64E38502-06D2-4E51-82FE-464E052045F9}" type="slidenum">
-              <a:rPr lang="en-GB" smtClean="0">
-                <a:solidFill>
-                  <a:srgbClr val="E8ECF4"/>
-                </a:solidFill>
-              </a:rPr>
-              <a:pPr algn="l"/>
+            <a:r>
+              <a:rPr lang="en-GB" smtClean="0" sz="900">
+                <a:solidFill>
+                  <a:srgbClr val="9aa1b2"/>
+                </a:solidFill>
+              </a:rPr>
               <a:t>8</a:t>
-            </a:fld>
+            </a:r>
             <a:endParaRPr lang="en-GB"/>
           </a:p>
         </p:txBody>
@@ -31719,7 +31622,7 @@
           </a:prstGeom>
         </p:spPr>
         <p:txBody>
-          <a:bodyPr/>
+          <a:bodyPr wrap="none"/>
           <a:lstStyle/>
           <a:p>
             <a:r>
@@ -31752,7 +31655,7 @@
           </a:prstGeom>
         </p:spPr>
         <p:txBody>
-          <a:bodyPr/>
+          <a:bodyPr wrap="none"/>
           <a:lstStyle/>
           <a:p>
             <a:r>
@@ -31784,19 +31687,18 @@
           </a:prstGeom>
         </p:spPr>
         <p:txBody>
-          <a:bodyPr/>
+          <a:bodyPr wrap="none"/>
           <a:lstStyle/>
           <a:p>
             <a:pPr algn="l"/>
-            <a:fld id="{64E38502-06D2-4E51-82FE-464E052045F9}" type="slidenum">
-              <a:rPr lang="en-GB" smtClean="0">
-                <a:solidFill>
-                  <a:srgbClr val="E8ECF4"/>
-                </a:solidFill>
-              </a:rPr>
-              <a:pPr algn="l"/>
+            <a:r>
+              <a:rPr lang="en-GB" smtClean="0" sz="900">
+                <a:solidFill>
+                  <a:srgbClr val="9aa1b2"/>
+                </a:solidFill>
+              </a:rPr>
               <a:t>9</a:t>
-            </a:fld>
+            </a:r>
             <a:endParaRPr lang="en-GB"/>
           </a:p>
         </p:txBody>

</xml_diff>